<commit_message>
Add official GraspVLA simulation workflow
</commit_message>
<xml_diff>
--- a/docs/slides/graspvla_inner_workings.pptx
+++ b/docs/slides/graspvla_inner_workings.pptx
@@ -3644,6 +3644,14 @@
             </a:pPr>
             <a:r>
               <a:t>Official validate_server.py and offline_test.py both succeeded on em14</a:t>
+            </a:r>
+          </a:p>
+          <a:p>
+            <a:pPr>
+              <a:defRPr sz="2200"/>
+            </a:pPr>
+            <a:r>
+              <a:t>Official playground.py and evaluate_libero_tasks.py now run in gb-graspvla-sim</a:t>
             </a:r>
           </a:p>
           <a:p>

</xml_diff>

<commit_message>
Add complete official GraspVLA simulation workflow
</commit_message>
<xml_diff>
--- a/docs/slides/graspvla_inner_workings.pptx
+++ b/docs/slides/graspvla_inner_workings.pptx
@@ -3659,6 +3659,22 @@
               <a:defRPr sz="2200"/>
             </a:pPr>
             <a:r>
+              <a:t>Official complete sim batch is done: playground 8/10, libero_object 482/500, libero_10 325/350, libero_goal 336/350</a:t>
+            </a:r>
+          </a:p>
+          <a:p>
+            <a:pPr>
+              <a:defRPr sz="2200"/>
+            </a:pPr>
+            <a:r>
+              <a:t>The 350 denominators are expected: libero_10 exposes 7 tasks and libero_goal skips 3 invalid tasks</a:t>
+            </a:r>
+          </a:p>
+          <a:p>
+            <a:pPr>
+              <a:defRPr sz="2200"/>
+            </a:pPr>
+            <a:r>
               <a:t>GraspVLA smoke success 1/1 at about 377 ms</a:t>
             </a:r>
           </a:p>
@@ -3733,6 +3749,14 @@
         <p:txBody>
           <a:bodyPr/>
           <a:lstStyle/>
+          <a:p>
+            <a:pPr>
+              <a:defRPr sz="2200"/>
+            </a:pPr>
+            <a:r>
+              <a:t>Use the complete official GraspVLA sim run as the anchor reference</a:t>
+            </a:r>
+          </a:p>
           <a:p>
             <a:pPr>
               <a:defRPr sz="2200"/>

</xml_diff>